<commit_message>
Update wells drilled to 75 in brochures and site mockup
Co-Authored-By: Claude Sonnet 5.5 <noreply@anthropic.com>
Claude-Session: https://claude.ai/code/session_01XPwnZBmWUGhvYebrP3X3Z2
</commit_message>
<xml_diff>
--- a/Plaquette_Enedril_6p.pptx
+++ b/Plaquette_Enedril_6p.pptx
@@ -3907,7 +3907,7 @@
                 <a:cs typeface="Ubuntu Mono"/>
                 <a:sym typeface="Ubuntu Mono"/>
               </a:rPr>
-              <a:t>60</a:t>
+              <a:t>75</a:t>
             </a:r>
           </a:p>
         </p:txBody>
@@ -7978,7 +7978,7 @@
                 <a:cs typeface="Ubuntu Mono"/>
                 <a:sym typeface="Ubuntu Mono"/>
               </a:rPr>
-              <a:t>98,500 m drilled · 60 wells · up to 3,000 m TVD · geothermal, oil &amp; gas, underground gas storage</a:t>
+              <a:t>98,500 m drilled · 75 wells · up to 3,000 m TVD · geothermal, oil &amp; gas, underground gas storage</a:t>
             </a:r>
           </a:p>
         </p:txBody>

</xml_diff>

<commit_message>
Présentation Enedril en français (paysage et portrait), plaquette EN portrait alignée sur les modifications
Co-Authored-By: Claude Sonnet 5.5 <noreply@anthropic.com>
Claude-Session: https://claude.ai/code/session_01XPwnZBmWUGhvYebrP3X3Z2
</commit_message>
<xml_diff>
--- a/Plaquette_Enedril_6p.pptx
+++ b/Plaquette_Enedril_6p.pptx
@@ -3715,7 +3715,7 @@
                 <a:cs typeface="Ubuntu Mono"/>
                 <a:sym typeface="Ubuntu Mono"/>
               </a:rPr>
-              <a:t>Enedril (formerly Mustang Oil Services) is an independent French company founded in 2013 and specialised in directional drilling, fishing and well intervention for geothermal, oil &amp; gas and underground gas storage projects, in France and abroad. Run since 2022 by Fabien and Alexis, it combines solid field experience with technical know-how, and is known for being fast, flexible and easy to work with.</a:t>
+              <a:t>Enedril is an independent French company founded in 2013, specialised in directional drilling, fishing and well intervention for geothermal, oil &amp; gas and underground gas storage projects, in France and abroad. Run since 2022 by Fabien and Alexis, it combines solid field experience with technical know-how, and is known for being fast, flexible and easy to work with.</a:t>
             </a:r>
           </a:p>
         </p:txBody>
@@ -4278,7 +4278,7 @@
                 <a:cs typeface="Ubuntu Mono"/>
                 <a:sym typeface="Ubuntu Mono"/>
               </a:rPr>
-              <a:t>Since 2021 we operate from Lons, near Pau, with two fully equipped workshops of more than 1,000 m², a 5 t overhead crane, a break-out unit, a jar tester, lathe, milling and grinding machines and a separate welding shop.</a:t>
+              <a:t>Since 2013 we operate from Lons, near Pau, with two fully equipped workshops of more than 1,000 m², a 5 t overhead crane, a break-out unit, a jar tester, lathe, milling and grinding machines and a separate welding shop.</a:t>
             </a:r>
           </a:p>
           <a:p>
@@ -6545,7 +6545,7 @@
                 <a:cs typeface="Ubuntu Mono"/>
                 <a:sym typeface="Ubuntu Mono"/>
               </a:rPr>
-              <a:t>Rebranding: Mustang Oil Services becomes Enedril, Fishing and Drilling Solutions.</a:t>
+              <a:t>Rebranding: Mustang Services becomes Enedril, Fishing and Drilling Solutions.</a:t>
             </a:r>
           </a:p>
         </p:txBody>

</xml_diff>